<commit_message>
Cierra GLOBAL y H1 antes de iniciar H2
</commit_message>
<xml_diff>
--- a/02-PROFESORADO/03-PRESENTACIONES/POR-SESION/h1/S211-constantes-presentacion.pptx
+++ b/02-PROFESORADO/03-PRESENTACIONES/POR-SESION/h1/S211-constantes-presentacion.pptx
@@ -29,7 +29,6 @@
     <p:sldId id="277" r:id="rId29"/>
     <p:sldId id="278" r:id="rId30"/>
     <p:sldId id="279" r:id="rId31"/>
-    <p:sldId id="280" r:id="rId32"/>
   </p:sldIdLst>
   <p:sldSz cx="12191695" cy="6858000" type="screen4x3"/>
   <p:notesSz cx="6858000" cy="9144000"/>
@@ -737,7 +736,7 @@
           </a:p>
           <a:p>
             <a:r>
-              <a:t>S211 parte de variables y tipos ya trabajados en S210. No introduce `Scanner`, parseo ni casting como contenido central; la entrada y las conversiones corresponden a S212. Las expresiones lógicas aparecen solo para reconocer resultados con tipo y no adelantan el trabajo de decisiones de S213.</a:t>
+              <a:t>S211 parte de variables y tipos ya trabajados en S210. No introduce `Scanner`, parseo ni casting como contenido central; la entrada, las conversiones, el cálculo y la comparación booleana observable corresponden a S212. Las expresiones lógicas aparecen solo para reconocer resultados con tipo y no adelantan las decisiones con control de flujo de H2.</a:t>
             </a:r>
           </a:p>
           <a:p/>
@@ -2203,89 +2202,6 @@
           </a:p>
           <a:p>
             <a:r>
-              <a:t>Reloj fuente 38–43 min: duración compartida 300 segundos. Trabajo: Integrar constante, variable, operación, actualización y salida; ejecutar y explicar discrepancias. Función del soporte: apoyo al trabajo.</a:t>
-            </a:r>
-          </a:p>
-          <a:p/>
-          <a:p/>
-        </p:txBody>
-      </p:sp>
-      <p:sp>
-        <p:nvSpPr>
-          <p:cNvPr id="4" name="Slide Number Placeholder 3"/>
-          <p:cNvSpPr>
-            <a:spLocks noGrp="1"/>
-          </p:cNvSpPr>
-          <p:nvPr>
-            <p:ph type="sldNum" idx="5" sz="quarter"/>
-          </p:nvPr>
-        </p:nvSpPr>
-        <p:spPr/>
-      </p:sp>
-    </p:spTree>
-  </p:cSld>
-  <p:clrMapOvr>
-    <a:masterClrMapping/>
-  </p:clrMapOvr>
-</p:notes>
-</file>
-
-<file path=ppt/notesSlides/notesSlide25.xml><?xml version="1.0" encoding="utf-8"?>
-<p:notes xmlns:a="http://schemas.openxmlformats.org/drawingml/2006/main" xmlns:p="http://schemas.openxmlformats.org/presentationml/2006/main" xmlns:r="http://schemas.openxmlformats.org/officeDocument/2006/relationships">
-  <p:cSld>
-    <p:spTree>
-      <p:nvGrpSpPr>
-        <p:cNvPr id="1" name=""/>
-        <p:cNvGrpSpPr/>
-        <p:nvPr/>
-      </p:nvGrpSpPr>
-      <p:grpSpPr>
-        <a:xfrm>
-          <a:off x="0" y="0"/>
-          <a:ext cx="0" cy="0"/>
-          <a:chOff x="0" y="0"/>
-          <a:chExt cx="0" cy="0"/>
-        </a:xfrm>
-      </p:grpSpPr>
-      <p:sp>
-        <p:nvSpPr>
-          <p:cNvPr id="2" name="Slide Image Placeholder 1"/>
-          <p:cNvSpPr>
-            <a:spLocks noGrp="1"/>
-          </p:cNvSpPr>
-          <p:nvPr>
-            <p:ph type="sldImg" idx="2"/>
-          </p:nvPr>
-        </p:nvSpPr>
-        <p:spPr/>
-      </p:sp>
-      <p:sp>
-        <p:nvSpPr>
-          <p:cNvPr id="3" name="Notes Placeholder 2"/>
-          <p:cNvSpPr>
-            <a:spLocks noGrp="1"/>
-          </p:cNvSpPr>
-          <p:nvPr>
-            <p:ph type="body" idx="3" sz="quarter"/>
-          </p:nvPr>
-        </p:nvSpPr>
-        <p:spPr/>
-        <p:txBody>
-          <a:bodyPr/>
-          <a:lstStyle/>
-          <a:p>
-            <a:r>
-              <a:t>NOTAS DEL PRESENTADOR</a:t>
-            </a:r>
-          </a:p>
-          <a:p/>
-          <a:p>
-            <a:r>
-              <a:t>TIEMPO ORIENTATIVO (no proyectado)</a:t>
-            </a:r>
-          </a:p>
-          <a:p>
-            <a:r>
               <a:t>Reloj fuente 43–45 min: duración compartida 120 segundos. Trabajo: Comprobar la comprensión y cerrar. Función del soporte: comprobación individual.</a:t>
             </a:r>
           </a:p>
@@ -2785,7 +2701,7 @@
           <a:p/>
           <a:p>
             <a:r>
-              <a:t>Antes de ejecutar, pregunta por el valor y el tipo esperado. Las expresiones booleanas se utilizan aquí solo para reconocer que una expresión produce un resultado tipado; comparaciones, lógica y decisiones se desarrollan en S213.</a:t>
+              <a:t>Antes de ejecutar, pregunta por el valor y el tipo esperado. Las expresiones booleanas se utilizan aquí solo para reconocer que una expresión produce un resultado tipado; la comparación obligatoria se integra en S212 y las decisiones con control de flujo comienzan en H2.</a:t>
             </a:r>
           </a:p>
         </p:txBody>
@@ -2883,7 +2799,7 @@
           <a:p/>
           <a:p>
             <a:r>
-              <a:t>Antes de ejecutar, pregunta por el valor y el tipo esperado. Las expresiones booleanas se utilizan aquí solo para reconocer que una expresión produce un resultado tipado; comparaciones, lógica y decisiones se desarrollan en S213.</a:t>
+              <a:t>Antes de ejecutar, pregunta por el valor y el tipo esperado. Las expresiones booleanas se utilizan aquí solo para reconocer que una expresión produce un resultado tipado; la comparación obligatoria se integra en S212 y las decisiones con control de flujo comienzan en H2.</a:t>
             </a:r>
           </a:p>
         </p:txBody>
@@ -6158,7 +6074,7 @@
               </a:defRPr>
             </a:pPr>
             <a:r>
-              <a:t>Modalidad publicada: Equipo</a:t>
+              <a:t>Modalidad publicada: Individual → contraste por parejas</a:t>
             </a:r>
           </a:p>
         </p:txBody>
@@ -6212,7 +6128,7 @@
   </p:clrMapOvr>
   <p:extLst>
     <p:ext uri="urn:minijarvis:semantic-render:v1">
-      <ns0:renderMetadata xmlns:ns0="urn:minijarvis:semantic-render:v1">{"session": "211", "source_files": {"teacher": "/mnt/compartido/Programación-26-27/Minijarvis/02-PROFESORADO/02-SESIONES/h1/S211-constantes-docente.md", "student_fallback": "/mnt/compartido/Programación-26-27/Minijarvis/01-ALUMNADO/03-SESIONES/h1/S211-constantes-alumnado.md"}, "layout": "title", "plan_index": 0, "recognition": false, "unit_ids": ["unit-0", "unit-1", "unit-2", "unit-3", "unit-15", "unit-16", "unit-18", "unit-21", "unit-22", "unit-23", "unit-24", "unit-25", "unit-26", "unit-27"], "roles": {"unit-0": "core", "unit-1": "core", "unit-2": "core", "unit-3": "core", "unit-15": "core", "unit-16": "core", "unit-18": "recognition", "unit-21": "core", "unit-22": "core", "unit-23": "core", "unit-24": "core", "unit-25": "core", "unit-26": "core", "unit-27": "core"}, "source_refs": [{"source": "teacher", "heading": "Qué vas a aprender", "block_index": 0, "fragment": 0}, {"source": "teacher", "heading": "Antes de entrar en clase", "block_index": 1, "fragment": 0}, {"source": "teacher", "heading": "Apertura docente", "block_index": 2, "fragment": 0}, {"source": "teacher", "heading": "Temporalización orientativa", "block_index": 3, "fragment": 0}, {"source": "teacher", "heading": "Observación docente", "block_index": 17, "fragment": 0}, {"source": "teacher", "heading": "Andamiaje ante bloqueos", "block_index": 18, "fragment": 0}, {"source": "teacher", "heading": "Límite de la sesión", "block_index": 20, "fragment": 0}, {"source": "teacher", "heading": "Temporalización orientativa", "block_index": 3, "fragment": 0}, {"source": "teacher", "heading": "Temporalización orientativa", "block_index": 3, "fragment": 0}, {"source": "teacher", "heading": "Temporalización orientativa", "block_index": 3, "fragment": 0}, {"source": "teacher", "heading": "Temporalización orientativa", "block_index": 3, "fragment": 0}, {"source": "teacher", "heading": "Temporalización orientativa", "block_index": 3, "fragment": 0}, {"source": "teacher", "heading": "Temporalización orientativa", "block_index": 3, "fragment": 0}, {"source": "teacher", "heading": "Temporalización orientativa", "block_index": 3, "fragment": 0}], "visible_sources": [], "notes_sources": [{"function": "preparation", "heading": "Antes de entrar en clase", "sha256": "976b9dd451159130e5e327555cce74c5829765b52ef33716ad6ec408a2a66923"}, {"function": "explanations", "heading": "Apertura docente", "sha256": "aba648f76cad8b1cc54e87b4d9c0aad7a74096e41f45c6a5d82acb961899719f"}, {"function": "explanations", "heading": "Apertura docente", "sha256": "ce1f0857d26380a2db4fa3a708eee1789fad11e95e032b739b314d5785066212"}, {"function": "explanations", "heading": "Apertura docente", "sha256": "e5ec778dc0ff64fe2d17b41ac3e208cabc9e51f34e3a91c25c0177b1e98ae9fc"}, {"function": "explanations", "heading": "Apertura docente", "sha256": "961a36ac1093894fee007ef1fca1e4742fada4cd15b2c78a5cc5f7df8caa61e0"}, {"function": "timeline_context", "heading": "Temporalización orientativa", "sha256": "fe7ede0a952730893372452faa99dcdd09289ad68a28cafc3370de385ab020cf"}, {"function": "observation", "heading": "Observación docente", "sha256": "2e9c80d870522826e7567ba0fa7d8a1669df1afe27478998cd1b11535b2abe46"}, {"function": "observation", "heading": "Observación docente", "sha256": "fa109026666097671080037117c7e72c68714fb73a51af0ac09a6985d1f72a45"}, {"function": "scaffolding", "heading": "Andamiaje ante bloqueos", "sha256": "6789281f6c65eb1a281db9f861b5fe884cd2684b0bb07e471d4695b1e147117b"}, {"function": "scaffolding", "heading": "Andamiaje ante bloqueos", "sha256": "8a89977cd43faa597bf663e19509ffd2ec73e08d2c319f000d9305609d0e1af0"}, {"function": "other", "heading": "Límite de la sesión", "sha256": "a049055f530a241951132582c7667fbc5493024446b01dbe0e315ef426b38bc3"}, {"function": "timeline", "heading": "Temporalización orientativa", "sha256": "1438698420b4a98ebec8c1855fabce3d38d909f53a7e1e2949621ebe18cfc959"}, {"function": "timeline", "heading": "Temporalización orientativa", "sha256": "58d50d4294551b88f78c9303d7711d397b47b690440dcc99e389af91bd2ffc07"}, {"function": "timeline", "heading": "Temporalización orientativa", "sha256": "9202f15c35c34e4e90d85c432ae6933d117a77998f2ff75a5f566b6596d5a685"}, {"function": "timeline", "heading": "Temporalización orientativa", "sha256": "851bee345c95146bb1aafb34e50d13d32354b6c6f9a119250a9dd1934d6321b6"}, {"function": "timeline", "heading": "Temporalización orientativa", "sha256": "7e82f258f01736ed53a434714f4ea5a933384e48b0daa55b060500394a4adf4f"}, {"function": "timeline", "heading": "Temporalización orientativa", "sha256": "153023fd4fa29421d4abec6e167e5d52536d026d7952dd7c48977f004753a8b4"}, {"function": "timeline", "heading": "Temporalización orientativa", "sha256": "b121a354998520337bdf6f25824e9cd13b9daf9d17db016db960266b765e3399"}], "relations": {"source_supports_enriched": true}, "timeline_refs": [0], "composition": {"origin_slides": [1]}, "timing": {"seconds": 0, "allocations": [{"source_index": 0, "seconds": 0, "decision": "Intervalo compartido íntegro; propietario contable seleccionado por función de actividad y referencia timeline de unidad (identidad semántica en empates). Soporte, sin duplicación contable. Portada limitada a la apertura inicial: las referencias timeline presenter-only no convierten la portada en soporte de todos los tramos.", "source_time": "0–4 min", "source_seconds": 240, "is_owner": false, "function": "concepts"}], "clock_intervals": [0], "presenter_notes": "Reloj fuente 0–4 min: duración compartida 240 segundos. Trabajo: Presentar la finalidad y activar la distinción entre constante y variable. Función del soporte: explicación.", "shared_intervals": [{"source_index": 0, "source_time": "0–4 min", "seconds": 240, "is_owner": false, "function": "concepts", "action": "Presentar la finalidad y activar la distinción entre constante y variable.", "concurrent": false, "parallel_work": ""}]}, "code_blocks": [], "representation_needs": []}</ns0:renderMetadata>
+      <ns0:renderMetadata xmlns:ns0="urn:minijarvis:semantic-render:v1">{"session": "211", "source_files": {"teacher": "/mnt/compartido/Programación-26-27/Minijarvis/02-PROFESORADO/02-SESIONES/h1/S211-constantes-docente.md", "student_fallback": "/mnt/compartido/Programación-26-27/Minijarvis/01-ALUMNADO/03-SESIONES/h1/S211-constantes-alumnado.md"}, "layout": "title", "plan_index": 0, "recognition": false, "unit_ids": ["unit-0", "unit-1", "unit-2", "unit-3", "unit-15", "unit-16", "unit-18", "unit-20", "unit-21", "unit-22", "unit-23", "unit-24", "unit-25", "unit-26"], "roles": {"unit-0": "core", "unit-1": "core", "unit-2": "core", "unit-3": "core", "unit-15": "core", "unit-16": "core", "unit-18": "recognition", "unit-20": "core", "unit-21": "core", "unit-22": "core", "unit-23": "core", "unit-24": "core", "unit-25": "core", "unit-26": "core"}, "source_refs": [{"source": "teacher", "heading": "Qué vas a aprender", "block_index": 0, "fragment": 0}, {"source": "teacher", "heading": "Antes de entrar en clase", "block_index": 1, "fragment": 0}, {"source": "teacher", "heading": "Apertura docente", "block_index": 2, "fragment": 0}, {"source": "teacher", "heading": "Temporalización orientativa", "block_index": 3, "fragment": 0}, {"source": "teacher", "heading": "Observación docente", "block_index": 17, "fragment": 0}, {"source": "teacher", "heading": "Andamiaje ante bloqueos", "block_index": 18, "fragment": 0}, {"source": "teacher", "heading": "Límite de la sesión", "block_index": 20, "fragment": 0}, {"source": "teacher", "heading": "Temporalización orientativa", "block_index": 3, "fragment": 0}, {"source": "teacher", "heading": "Temporalización orientativa", "block_index": 3, "fragment": 0}, {"source": "teacher", "heading": "Temporalización orientativa", "block_index": 3, "fragment": 0}, {"source": "teacher", "heading": "Temporalización orientativa", "block_index": 3, "fragment": 0}, {"source": "teacher", "heading": "Temporalización orientativa", "block_index": 3, "fragment": 0}, {"source": "teacher", "heading": "Temporalización orientativa", "block_index": 3, "fragment": 0}, {"source": "teacher", "heading": "Temporalización orientativa", "block_index": 3, "fragment": 0}], "visible_sources": [], "notes_sources": [{"function": "preparation", "heading": "Antes de entrar en clase", "sha256": "976b9dd451159130e5e327555cce74c5829765b52ef33716ad6ec408a2a66923"}, {"function": "explanations", "heading": "Apertura docente", "sha256": "aba648f76cad8b1cc54e87b4d9c0aad7a74096e41f45c6a5d82acb961899719f"}, {"function": "explanations", "heading": "Apertura docente", "sha256": "ce1f0857d26380a2db4fa3a708eee1789fad11e95e032b739b314d5785066212"}, {"function": "explanations", "heading": "Apertura docente", "sha256": "e5ec778dc0ff64fe2d17b41ac3e208cabc9e51f34e3a91c25c0177b1e98ae9fc"}, {"function": "explanations", "heading": "Apertura docente", "sha256": "961a36ac1093894fee007ef1fca1e4742fada4cd15b2c78a5cc5f7df8caa61e0"}, {"function": "timeline_context", "heading": "Temporalización orientativa", "sha256": "fe7ede0a952730893372452faa99dcdd09289ad68a28cafc3370de385ab020cf"}, {"function": "observation", "heading": "Observación docente", "sha256": "2e9c80d870522826e7567ba0fa7d8a1669df1afe27478998cd1b11535b2abe46"}, {"function": "observation", "heading": "Observación docente", "sha256": "fa109026666097671080037117c7e72c68714fb73a51af0ac09a6985d1f72a45"}, {"function": "scaffolding", "heading": "Andamiaje ante bloqueos", "sha256": "6789281f6c65eb1a281db9f861b5fe884cd2684b0bb07e471d4695b1e147117b"}, {"function": "scaffolding", "heading": "Andamiaje ante bloqueos", "sha256": "8a89977cd43faa597bf663e19509ffd2ec73e08d2c319f000d9305609d0e1af0"}, {"function": "other", "heading": "Límite de la sesión", "sha256": "0c0ef4d0a8bb3c359f10b5dec3783be078434c8000ac882f3555d973cde300b1"}, {"function": "timeline", "heading": "Temporalización orientativa", "sha256": "1438698420b4a98ebec8c1855fabce3d38d909f53a7e1e2949621ebe18cfc959"}, {"function": "timeline", "heading": "Temporalización orientativa", "sha256": "58d50d4294551b88f78c9303d7711d397b47b690440dcc99e389af91bd2ffc07"}, {"function": "timeline", "heading": "Temporalización orientativa", "sha256": "9202f15c35c34e4e90d85c432ae6933d117a77998f2ff75a5f566b6596d5a685"}, {"function": "timeline", "heading": "Temporalización orientativa", "sha256": "851bee345c95146bb1aafb34e50d13d32354b6c6f9a119250a9dd1934d6321b6"}, {"function": "timeline", "heading": "Temporalización orientativa", "sha256": "7e82f258f01736ed53a434714f4ea5a933384e48b0daa55b060500394a4adf4f"}, {"function": "timeline", "heading": "Temporalización orientativa", "sha256": "153023fd4fa29421d4abec6e167e5d52536d026d7952dd7c48977f004753a8b4"}, {"function": "timeline", "heading": "Temporalización orientativa", "sha256": "b121a354998520337bdf6f25824e9cd13b9daf9d17db016db960266b765e3399"}], "relations": {"source_supports_enriched": true}, "timeline_refs": [0], "composition": {"origin_slides": [1]}, "timing": {"seconds": 0, "allocations": [{"source_index": 0, "seconds": 0, "decision": "Intervalo compartido íntegro; propietario contable seleccionado por función de actividad y referencia timeline de unidad (identidad semántica en empates). Soporte, sin duplicación contable. Portada limitada a la apertura inicial: las referencias timeline presenter-only no convierten la portada en soporte de todos los tramos.", "source_time": "0–4 min", "source_seconds": 240, "is_owner": false, "function": "concepts"}], "clock_intervals": [0], "presenter_notes": "Reloj fuente 0–4 min: duración compartida 240 segundos. Trabajo: Presentar la finalidad y activar la distinción entre constante y variable. Función del soporte: explicación.", "shared_intervals": [{"source_index": 0, "source_time": "0–4 min", "seconds": 240, "is_owner": false, "function": "concepts", "action": "Presentar la finalidad y activar la distinción entre constante y variable.", "concurrent": false, "parallel_work": ""}]}, "code_blocks": [], "representation_needs": []}</ns0:renderMetadata>
     </p:ext>
   </p:extLst>
 </p:sld>
@@ -11499,7 +11415,7 @@
               </a:defRPr>
             </a:pPr>
             <a:r>
-              <a:t>Seguridad y uso de IA</a:t>
+              <a:t>Comprueba lo aprendido</a:t>
             </a:r>
           </a:p>
         </p:txBody>
@@ -11548,14 +11464,63 @@
       </p:sp>
       <p:sp>
         <p:nvSpPr>
-          <p:cNvPr id="5" name="Acción" descr="Acción"/>
-          <p:cNvSpPr txBox="1"/>
-          <p:nvPr/>
-        </p:nvSpPr>
-        <p:spPr>
-          <a:xfrm>
-            <a:off x="640080" y="1406652"/>
-            <a:ext cx="10881360" cy="443992"/>
+          <p:cNvPr id="5" name="Contenido" descr="Contenido"/>
+          <p:cNvSpPr txBox="1"/>
+          <p:nvPr/>
+        </p:nvSpPr>
+        <p:spPr>
+          <a:xfrm>
+            <a:off x="640080" y="1417320"/>
+            <a:ext cx="10881360" cy="1338072"/>
+          </a:xfrm>
+          <a:prstGeom prst="rect">
+            <a:avLst/>
+          </a:prstGeom>
+          <a:solidFill>
+            <a:srgbClr val="2F5BA8"/>
+          </a:solidFill>
+        </p:spPr>
+        <p:txBody>
+          <a:bodyPr wrap="square" lIns="109728" rIns="109728" tIns="73152" bIns="73152">
+            <a:noAutofit/>
+          </a:bodyPr>
+          <a:lstStyle/>
+          <a:p>
+            <a:pPr>
+              <a:lnSpc>
+                <a:spcPts val="3080"/>
+              </a:lnSpc>
+              <a:spcAft>
+                <a:spcPts val="0"/>
+              </a:spcAft>
+              <a:defRPr sz="2800" b="1">
+                <a:solidFill>
+                  <a:srgbClr val="FFFFFF"/>
+                </a:solidFill>
+                <a:latin typeface="Liberation Sans"/>
+              </a:defRPr>
+            </a:pPr>
+            <a:r>
+              <a:rPr>
+                <a:solidFill>
+                  <a:srgbClr val="FFFFFF"/>
+                </a:solidFill>
+              </a:rPr>
+              <a:t>¿Por qué 5 / 2 produce 2, qué cambian los paréntesis, qué significa % y cómo evoluciona una variable con +=, -=, ++ o --?</a:t>
+            </a:r>
+          </a:p>
+        </p:txBody>
+      </p:sp>
+      <p:sp>
+        <p:nvSpPr>
+          <p:cNvPr id="6" name="Contenido" descr="Contenido"/>
+          <p:cNvSpPr txBox="1"/>
+          <p:nvPr/>
+        </p:nvSpPr>
+        <p:spPr>
+          <a:xfrm>
+            <a:off x="640080" y="2846832"/>
+            <a:ext cx="10881360" cy="946912"/>
           </a:xfrm>
           <a:prstGeom prst="rect">
             <a:avLst/>
@@ -11570,216 +11535,69 @@
           <a:p>
             <a:pPr>
               <a:lnSpc>
-                <a:spcPts val="2200"/>
-              </a:lnSpc>
-              <a:spcAft>
-                <a:spcPts val="0"/>
-              </a:spcAft>
-              <a:defRPr sz="2000" b="1">
-                <a:solidFill>
-                  <a:srgbClr val="2F5BA8"/>
-                </a:solidFill>
-                <a:latin typeface="Liberation Sans"/>
-              </a:defRPr>
-            </a:pPr>
-            <a:r>
-              <a:t>QUÉ HACER</a:t>
-            </a:r>
-          </a:p>
-        </p:txBody>
-      </p:sp>
-      <p:sp>
-        <p:nvSpPr>
-          <p:cNvPr id="6" name="Acción o criterio 0" descr="Acción o criterio 0"/>
-          <p:cNvSpPr txBox="1"/>
-          <p:nvPr/>
-        </p:nvSpPr>
-        <p:spPr>
-          <a:xfrm>
-            <a:off x="640080" y="1987804"/>
-            <a:ext cx="5257800" cy="1170432"/>
+                <a:spcPts val="3080"/>
+              </a:lnSpc>
+              <a:spcAft>
+                <a:spcPts val="0"/>
+              </a:spcAft>
+              <a:defRPr sz="2800" b="0">
+                <a:solidFill>
+                  <a:srgbClr val="1C2330"/>
+                </a:solidFill>
+                <a:latin typeface="Liberation Sans"/>
+              </a:defRPr>
+            </a:pPr>
+            <a:r>
+              <a:t>Una operación no está demostrada porque el código compile.</a:t>
+            </a:r>
+          </a:p>
+        </p:txBody>
+      </p:sp>
+      <p:sp>
+        <p:nvSpPr>
+          <p:cNvPr id="7" name="Contenido" descr="Contenido"/>
+          <p:cNvSpPr txBox="1"/>
+          <p:nvPr/>
+        </p:nvSpPr>
+        <p:spPr>
+          <a:xfrm>
+            <a:off x="640080" y="3885184"/>
+            <a:ext cx="10881360" cy="1729232"/>
           </a:xfrm>
           <a:prstGeom prst="rect">
             <a:avLst/>
           </a:prstGeom>
           <a:solidFill>
-            <a:srgbClr val="FFFFFF"/>
+            <a:srgbClr val="2F5BA8"/>
           </a:solidFill>
-          <a:ln>
-            <a:solidFill>
-              <a:srgbClr val="2F5BA8"/>
-            </a:solidFill>
-          </a:ln>
-        </p:spPr>
-        <p:txBody>
-          <a:bodyPr wrap="square" lIns="109728" rIns="109728" tIns="73152" bIns="73152">
-            <a:noAutofit/>
-          </a:bodyPr>
-          <a:lstStyle/>
-          <a:p>
-            <a:pPr>
-              <a:lnSpc>
-                <a:spcPts val="2640"/>
-              </a:lnSpc>
-              <a:spcAft>
-                <a:spcPts val="0"/>
-              </a:spcAft>
-              <a:defRPr sz="2400" b="0">
-                <a:solidFill>
-                  <a:srgbClr val="1C2330"/>
-                </a:solidFill>
-                <a:latin typeface="Liberation Sans"/>
-              </a:defRPr>
-            </a:pPr>
-            <a:r>
-              <a:t>Trabaja únicamente con datos ficticios.</a:t>
-            </a:r>
-          </a:p>
-        </p:txBody>
-      </p:sp>
-      <p:sp>
-        <p:nvSpPr>
-          <p:cNvPr id="7" name="Acción o criterio 1" descr="Acción o criterio 1"/>
-          <p:cNvSpPr txBox="1"/>
-          <p:nvPr/>
-        </p:nvSpPr>
-        <p:spPr>
-          <a:xfrm>
-            <a:off x="6080760" y="1987804"/>
-            <a:ext cx="5257800" cy="1170432"/>
-          </a:xfrm>
-          <a:prstGeom prst="rect">
-            <a:avLst/>
-          </a:prstGeom>
-          <a:solidFill>
-            <a:srgbClr val="FFFFFF"/>
-          </a:solidFill>
-          <a:ln>
-            <a:solidFill>
-              <a:srgbClr val="2F5BA8"/>
-            </a:solidFill>
-          </a:ln>
-        </p:spPr>
-        <p:txBody>
-          <a:bodyPr wrap="square" lIns="109728" rIns="109728" tIns="73152" bIns="73152">
-            <a:noAutofit/>
-          </a:bodyPr>
-          <a:lstStyle/>
-          <a:p>
-            <a:pPr>
-              <a:lnSpc>
-                <a:spcPts val="2640"/>
-              </a:lnSpc>
-              <a:spcAft>
-                <a:spcPts val="0"/>
-              </a:spcAft>
-              <a:defRPr sz="2400" b="0">
-                <a:solidFill>
-                  <a:srgbClr val="1C2330"/>
-                </a:solidFill>
-                <a:latin typeface="Liberation Sans"/>
-              </a:defRPr>
-            </a:pPr>
-            <a:r>
-              <a:t>No escribas contraseñas, tokens, claves API ni datos personales.</a:t>
-            </a:r>
-          </a:p>
-        </p:txBody>
-      </p:sp>
-      <p:sp>
-        <p:nvSpPr>
-          <p:cNvPr id="8" name="Acción o criterio 2" descr="Acción o criterio 2"/>
-          <p:cNvSpPr txBox="1"/>
-          <p:nvPr/>
-        </p:nvSpPr>
-        <p:spPr>
-          <a:xfrm>
-            <a:off x="640080" y="3249676"/>
-            <a:ext cx="5257800" cy="1840991"/>
-          </a:xfrm>
-          <a:prstGeom prst="rect">
-            <a:avLst/>
-          </a:prstGeom>
-          <a:solidFill>
-            <a:srgbClr val="FFFFFF"/>
-          </a:solidFill>
-          <a:ln>
-            <a:solidFill>
-              <a:srgbClr val="2F5BA8"/>
-            </a:solidFill>
-          </a:ln>
-        </p:spPr>
-        <p:txBody>
-          <a:bodyPr wrap="square" lIns="109728" rIns="109728" tIns="73152" bIns="73152">
-            <a:noAutofit/>
-          </a:bodyPr>
-          <a:lstStyle/>
-          <a:p>
-            <a:pPr>
-              <a:lnSpc>
-                <a:spcPts val="2640"/>
-              </a:lnSpc>
-              <a:spcAft>
-                <a:spcPts val="0"/>
-              </a:spcAft>
-              <a:defRPr sz="2400" b="0">
-                <a:solidFill>
-                  <a:srgbClr val="1C2330"/>
-                </a:solidFill>
-                <a:latin typeface="Liberation Sans"/>
-              </a:defRPr>
-            </a:pPr>
-            <a:r>
-              <a:t>Si utilizas IA en un uso permitido, registra qué pediste, qué recibiste, qué cambiaste y cómo lo comprobaste.</a:t>
-            </a:r>
-          </a:p>
-        </p:txBody>
-      </p:sp>
-      <p:sp>
-        <p:nvSpPr>
-          <p:cNvPr id="9" name="Acción o criterio 3" descr="Acción o criterio 3"/>
-          <p:cNvSpPr txBox="1"/>
-          <p:nvPr/>
-        </p:nvSpPr>
-        <p:spPr>
-          <a:xfrm>
-            <a:off x="6080760" y="3249676"/>
-            <a:ext cx="5257800" cy="1840991"/>
-          </a:xfrm>
-          <a:prstGeom prst="rect">
-            <a:avLst/>
-          </a:prstGeom>
-          <a:solidFill>
-            <a:srgbClr val="FFFFFF"/>
-          </a:solidFill>
-          <a:ln>
-            <a:solidFill>
-              <a:srgbClr val="2F5BA8"/>
-            </a:solidFill>
-          </a:ln>
-        </p:spPr>
-        <p:txBody>
-          <a:bodyPr wrap="square" lIns="109728" rIns="109728" tIns="73152" bIns="73152">
-            <a:noAutofit/>
-          </a:bodyPr>
-          <a:lstStyle/>
-          <a:p>
-            <a:pPr>
-              <a:lnSpc>
-                <a:spcPts val="2640"/>
-              </a:lnSpc>
-              <a:spcAft>
-                <a:spcPts val="0"/>
-              </a:spcAft>
-              <a:defRPr sz="2400" b="0">
-                <a:solidFill>
-                  <a:srgbClr val="1C2330"/>
-                </a:solidFill>
-                <a:latin typeface="Liberation Sans"/>
-              </a:defRPr>
-            </a:pPr>
-            <a:r>
-              <a:t>Los ejemplos de Laura solo se consultan después del intento propio.</a:t>
+        </p:spPr>
+        <p:txBody>
+          <a:bodyPr wrap="square" lIns="109728" rIns="109728" tIns="73152" bIns="73152">
+            <a:noAutofit/>
+          </a:bodyPr>
+          <a:lstStyle/>
+          <a:p>
+            <a:pPr>
+              <a:lnSpc>
+                <a:spcPts val="3080"/>
+              </a:lnSpc>
+              <a:spcAft>
+                <a:spcPts val="0"/>
+              </a:spcAft>
+              <a:defRPr sz="2800" b="1">
+                <a:solidFill>
+                  <a:srgbClr val="FFFFFF"/>
+                </a:solidFill>
+                <a:latin typeface="Liberation Sans"/>
+              </a:defRPr>
+            </a:pPr>
+            <a:r>
+              <a:rPr>
+                <a:solidFill>
+                  <a:srgbClr val="FFFFFF"/>
+                </a:solidFill>
+              </a:rPr>
+              <a:t>¿Qué dato has tratado como constante y por qué, qué expresión has calculado, dónde queda su resultado y cómo sabes que la salida coincide con tu predicción?</a:t>
             </a:r>
           </a:p>
         </p:txBody>
@@ -11791,301 +11609,7 @@
   </p:clrMapOvr>
   <p:extLst>
     <p:ext uri="urn:minijarvis:semantic-render:v1">
-      <ns0:renderMetadata xmlns:ns0="urn:minijarvis:semantic-render:v1">{"session": "211", "source_files": {"teacher": "/mnt/compartido/Programación-26-27/Minijarvis/02-PROFESORADO/02-SESIONES/h1/S211-constantes-docente.md", "student_fallback": "/mnt/compartido/Programación-26-27/Minijarvis/01-ALUMNADO/03-SESIONES/h1/S211-constantes-alumnado.md"}, "layout": "activity", "plan_index": 6, "recognition": false, "unit_ids": ["unit-20"], "roles": {"unit-20": "core"}, "source_refs": [{"source": "student_fallback", "heading": "Seguridad y uso de IA", "block_index": null, "fragment": 0}], "visible_sources": [{"index": 7, "sha256": "61337aa7d62b810fc872b64ccf50a7b9620d423d2be91b3dfff6d304f2bec734"}], "notes_sources": [], "relations": {"unit_relations": {"unit-20": {}}, "schedule": null, "source_supports_enriched": true}, "timeline_refs": [5], "composition": {"origin_slides": [29]}, "timing": {"seconds": 0, "allocations": [{"source_index": 5, "seconds": 0, "decision": "Intervalo compartido íntegro; propietario contable seleccionado por función de actividad y referencia timeline de unidad (identidad semántica en empates). Soporte, sin duplicación contable. ", "source_time": "38–43 min", "source_seconds": 300, "is_owner": false, "function": "security"}], "clock_intervals": [5], "presenter_notes": "Reloj fuente 38–43 min: duración compartida 300 segundos. Trabajo: Integrar constante, variable, operación, actualización y salida; ejecutar y explicar discrepancias. Función del soporte: apoyo al trabajo.", "shared_intervals": [{"source_index": 5, "source_time": "38–43 min", "seconds": 300, "is_owner": false, "function": "security", "action": "Integrar constante, variable, operación, actualización y salida; ejecutar y explicar discrepancias.", "concurrent": false, "parallel_work": ""}]}, "code_blocks": [], "representation_needs": []}</ns0:renderMetadata>
-    </p:ext>
-  </p:extLst>
-</p:sld>
-</file>
-
-<file path=ppt/slides/slide25.xml><?xml version="1.0" encoding="utf-8"?>
-<p:sld xmlns:a="http://schemas.openxmlformats.org/drawingml/2006/main" xmlns:p="http://schemas.openxmlformats.org/presentationml/2006/main" xmlns:r="http://schemas.openxmlformats.org/officeDocument/2006/relationships">
-  <p:cSld>
-    <p:bg>
-      <p:bgPr>
-        <a:solidFill>
-          <a:srgbClr val="F9F7F2"/>
-        </a:solidFill>
-        <a:effectLst/>
-      </p:bgPr>
-    </p:bg>
-    <p:spTree>
-      <p:nvGrpSpPr>
-        <p:cNvPr id="1" name=""/>
-        <p:cNvGrpSpPr/>
-        <p:nvPr/>
-      </p:nvGrpSpPr>
-      <p:grpSpPr/>
-      <p:sp>
-        <p:nvSpPr>
-          <p:cNvPr id="2" name="Contexto" descr="Contexto"/>
-          <p:cNvSpPr txBox="1"/>
-          <p:nvPr/>
-        </p:nvSpPr>
-        <p:spPr>
-          <a:xfrm>
-            <a:off x="640080" y="256032"/>
-            <a:ext cx="10881360" cy="443992"/>
-          </a:xfrm>
-          <a:prstGeom prst="rect">
-            <a:avLst/>
-          </a:prstGeom>
-          <a:noFill/>
-        </p:spPr>
-        <p:txBody>
-          <a:bodyPr wrap="square" lIns="109728" rIns="109728" tIns="73152" bIns="73152">
-            <a:noAutofit/>
-          </a:bodyPr>
-          <a:lstStyle/>
-          <a:p>
-            <a:pPr>
-              <a:lnSpc>
-                <a:spcPts val="2200"/>
-              </a:lnSpc>
-              <a:spcAft>
-                <a:spcPts val="0"/>
-              </a:spcAft>
-              <a:defRPr sz="2000" b="1">
-                <a:solidFill>
-                  <a:srgbClr val="2F5BA8"/>
-                </a:solidFill>
-                <a:latin typeface="Liberation Sans"/>
-              </a:defRPr>
-            </a:pPr>
-          </a:p>
-        </p:txBody>
-      </p:sp>
-      <p:sp>
-        <p:nvSpPr>
-          <p:cNvPr id="3" name="Idea principal" descr="Idea principal"/>
-          <p:cNvSpPr txBox="1"/>
-          <p:nvPr/>
-        </p:nvSpPr>
-        <p:spPr>
-          <a:xfrm>
-            <a:off x="640080" y="694944"/>
-            <a:ext cx="10881360" cy="594360"/>
-          </a:xfrm>
-          <a:prstGeom prst="rect">
-            <a:avLst/>
-          </a:prstGeom>
-          <a:noFill/>
-        </p:spPr>
-        <p:txBody>
-          <a:bodyPr wrap="square" lIns="109728" rIns="109728" tIns="73152" bIns="73152">
-            <a:noAutofit/>
-          </a:bodyPr>
-          <a:lstStyle/>
-          <a:p>
-            <a:pPr>
-              <a:lnSpc>
-                <a:spcPts val="3300"/>
-              </a:lnSpc>
-              <a:spcAft>
-                <a:spcPts val="0"/>
-              </a:spcAft>
-              <a:defRPr sz="3000" b="1">
-                <a:solidFill>
-                  <a:srgbClr val="1C2330"/>
-                </a:solidFill>
-                <a:latin typeface="Liberation Sans"/>
-              </a:defRPr>
-            </a:pPr>
-            <a:r>
-              <a:t>Comprueba lo aprendido</a:t>
-            </a:r>
-          </a:p>
-        </p:txBody>
-      </p:sp>
-      <p:sp>
-        <p:nvSpPr>
-          <p:cNvPr id="4" name="Sesión y procedencia" descr="Sesión y procedencia"/>
-          <p:cNvSpPr txBox="1"/>
-          <p:nvPr/>
-        </p:nvSpPr>
-        <p:spPr>
-          <a:xfrm>
-            <a:off x="640080" y="6428232"/>
-            <a:ext cx="10881360" cy="388112"/>
-          </a:xfrm>
-          <a:prstGeom prst="rect">
-            <a:avLst/>
-          </a:prstGeom>
-          <a:noFill/>
-        </p:spPr>
-        <p:txBody>
-          <a:bodyPr wrap="square" lIns="109728" rIns="109728" tIns="73152" bIns="73152">
-            <a:noAutofit/>
-          </a:bodyPr>
-          <a:lstStyle/>
-          <a:p>
-            <a:pPr>
-              <a:lnSpc>
-                <a:spcPts val="1760"/>
-              </a:lnSpc>
-              <a:spcAft>
-                <a:spcPts val="0"/>
-              </a:spcAft>
-              <a:defRPr sz="1600" b="0">
-                <a:solidFill>
-                  <a:srgbClr val="1C2330"/>
-                </a:solidFill>
-                <a:latin typeface="Liberation Sans"/>
-              </a:defRPr>
-            </a:pPr>
-            <a:r>
-              <a:t>S211 · H1 — Primer asistente ejecutable</a:t>
-            </a:r>
-          </a:p>
-        </p:txBody>
-      </p:sp>
-      <p:sp>
-        <p:nvSpPr>
-          <p:cNvPr id="5" name="Contenido" descr="Contenido"/>
-          <p:cNvSpPr txBox="1"/>
-          <p:nvPr/>
-        </p:nvSpPr>
-        <p:spPr>
-          <a:xfrm>
-            <a:off x="640080" y="1417320"/>
-            <a:ext cx="10881360" cy="1338072"/>
-          </a:xfrm>
-          <a:prstGeom prst="rect">
-            <a:avLst/>
-          </a:prstGeom>
-          <a:solidFill>
-            <a:srgbClr val="2F5BA8"/>
-          </a:solidFill>
-        </p:spPr>
-        <p:txBody>
-          <a:bodyPr wrap="square" lIns="109728" rIns="109728" tIns="73152" bIns="73152">
-            <a:noAutofit/>
-          </a:bodyPr>
-          <a:lstStyle/>
-          <a:p>
-            <a:pPr>
-              <a:lnSpc>
-                <a:spcPts val="3080"/>
-              </a:lnSpc>
-              <a:spcAft>
-                <a:spcPts val="0"/>
-              </a:spcAft>
-              <a:defRPr sz="2800" b="1">
-                <a:solidFill>
-                  <a:srgbClr val="FFFFFF"/>
-                </a:solidFill>
-                <a:latin typeface="Liberation Sans"/>
-              </a:defRPr>
-            </a:pPr>
-            <a:r>
-              <a:rPr>
-                <a:solidFill>
-                  <a:srgbClr val="FFFFFF"/>
-                </a:solidFill>
-              </a:rPr>
-              <a:t>¿Por qué 5 / 2 produce 2, qué cambian los paréntesis, qué significa % y cómo evoluciona una variable con +=, -=, ++ o --?</a:t>
-            </a:r>
-          </a:p>
-        </p:txBody>
-      </p:sp>
-      <p:sp>
-        <p:nvSpPr>
-          <p:cNvPr id="6" name="Contenido" descr="Contenido"/>
-          <p:cNvSpPr txBox="1"/>
-          <p:nvPr/>
-        </p:nvSpPr>
-        <p:spPr>
-          <a:xfrm>
-            <a:off x="640080" y="2846832"/>
-            <a:ext cx="10881360" cy="946912"/>
-          </a:xfrm>
-          <a:prstGeom prst="rect">
-            <a:avLst/>
-          </a:prstGeom>
-          <a:noFill/>
-        </p:spPr>
-        <p:txBody>
-          <a:bodyPr wrap="square" lIns="109728" rIns="109728" tIns="73152" bIns="73152">
-            <a:noAutofit/>
-          </a:bodyPr>
-          <a:lstStyle/>
-          <a:p>
-            <a:pPr>
-              <a:lnSpc>
-                <a:spcPts val="3080"/>
-              </a:lnSpc>
-              <a:spcAft>
-                <a:spcPts val="0"/>
-              </a:spcAft>
-              <a:defRPr sz="2800" b="0">
-                <a:solidFill>
-                  <a:srgbClr val="1C2330"/>
-                </a:solidFill>
-                <a:latin typeface="Liberation Sans"/>
-              </a:defRPr>
-            </a:pPr>
-            <a:r>
-              <a:t>Una operación no está demostrada porque el código compile.</a:t>
-            </a:r>
-          </a:p>
-        </p:txBody>
-      </p:sp>
-      <p:sp>
-        <p:nvSpPr>
-          <p:cNvPr id="7" name="Contenido" descr="Contenido"/>
-          <p:cNvSpPr txBox="1"/>
-          <p:nvPr/>
-        </p:nvSpPr>
-        <p:spPr>
-          <a:xfrm>
-            <a:off x="640080" y="3885184"/>
-            <a:ext cx="10881360" cy="1729232"/>
-          </a:xfrm>
-          <a:prstGeom prst="rect">
-            <a:avLst/>
-          </a:prstGeom>
-          <a:solidFill>
-            <a:srgbClr val="2F5BA8"/>
-          </a:solidFill>
-        </p:spPr>
-        <p:txBody>
-          <a:bodyPr wrap="square" lIns="109728" rIns="109728" tIns="73152" bIns="73152">
-            <a:noAutofit/>
-          </a:bodyPr>
-          <a:lstStyle/>
-          <a:p>
-            <a:pPr>
-              <a:lnSpc>
-                <a:spcPts val="3080"/>
-              </a:lnSpc>
-              <a:spcAft>
-                <a:spcPts val="0"/>
-              </a:spcAft>
-              <a:defRPr sz="2800" b="1">
-                <a:solidFill>
-                  <a:srgbClr val="FFFFFF"/>
-                </a:solidFill>
-                <a:latin typeface="Liberation Sans"/>
-              </a:defRPr>
-            </a:pPr>
-            <a:r>
-              <a:rPr>
-                <a:solidFill>
-                  <a:srgbClr val="FFFFFF"/>
-                </a:solidFill>
-              </a:rPr>
-              <a:t>¿Qué dato has tratado como constante y por qué, qué expresión has calculado, dónde queda su resultado y cómo sabes que la salida coincide con tu predicción?</a:t>
-            </a:r>
-          </a:p>
-        </p:txBody>
-      </p:sp>
-    </p:spTree>
-  </p:cSld>
-  <p:clrMapOvr>
-    <a:masterClrMapping/>
-  </p:clrMapOvr>
-  <p:extLst>
-    <p:ext uri="urn:minijarvis:semantic-render:v1">
-      <ns0:renderMetadata xmlns:ns0="urn:minijarvis:semantic-render:v1">{"session": "211", "source_files": {"teacher": "/mnt/compartido/Programación-26-27/Minijarvis/02-PROFESORADO/02-SESIONES/h1/S211-constantes-docente.md", "student_fallback": "/mnt/compartido/Programación-26-27/Minijarvis/01-ALUMNADO/03-SESIONES/h1/S211-constantes-alumnado.md"}, "layout": "closure", "plan_index": 7, "recognition": false, "unit_ids": ["unit-17", "unit-19"], "roles": {"unit-17": "core", "unit-19": "core"}, "source_refs": [{"source": "teacher", "heading": "Comprueba lo aprendido", "block_index": 19, "fragment": 0}, {"source": "teacher", "heading": "Al terminar", "block_index": 21, "fragment": 0}], "visible_sources": [{"index": 0, "sha256": "d1e883f1f673c17af930de84df20616b0e9672320f9b22c6a8df1e66e398200b"}, {"index": 2, "sha256": "139edc0da4c423e7db0c409a658663d5a0f2456a703f1ea36786e34fff0c98d3"}, {"index": 3, "sha256": "ed77adc5766e0f42b1d6cff68535cbcac28f722a78b754bfa501b904b5075277"}], "notes_sources": [{"function": "individual_check", "heading": "Comprueba lo aprendido", "sha256": "dae03982d930a360cc6f21f6182bdcfffd59c916b3cd04bb2bc0c7f6a450910a"}, {"function": "individual_check", "heading": "Comprueba lo aprendido", "sha256": "c54f205b33bd0dd1f4ec5e9ca0395c54a3e3633b76fe0bb5b87a0f6041c4f4f5"}, {"function": "continuity", "heading": "Al terminar", "sha256": "c5d760b9336aefe6ba9649ec169c61027094be686b87323b8f689f792abbf42a"}, {"function": "facilitation", "heading": "Comprueba lo aprendido", "sha256": "5ac270c14daf9145b5fa6b3260aaee7fce13571ee2fba5f4f556b6f5b86f5a90"}, {"function": "visible_detail", "heading": "Comprueba lo aprendido", "sha256": "139edc0da4c423e7db0c409a658663d5a0f2456a703f1ea36786e34fff0c98d3"}, {"function": "closure", "heading": "Comprueba lo aprendido", "sha256": "ed77adc5766e0f42b1d6cff68535cbcac28f722a78b754bfa501b904b5075277"}, {"function": "closure", "heading": "Comprueba lo aprendido", "sha256": "d1e883f1f673c17af930de84df20616b0e9672320f9b22c6a8df1e66e398200b"}, {"function": "closure", "heading": "Comprueba lo aprendido", "sha256": "ed77adc5766e0f42b1d6cff68535cbcac28f722a78b754bfa501b904b5075277"}, {"function": "closure", "heading": "Comprueba lo aprendido", "sha256": "d1e883f1f673c17af930de84df20616b0e9672320f9b22c6a8df1e66e398200b"}], "relations": {"unit_relations": {"unit-17": {"question_context": ["context", "question"]}}, "schedule": null, "source_supports_enriched": true}, "timeline_refs": [6], "composition": {"origin_slides": [30]}, "timing": {"seconds": 120, "allocations": [{"source_index": 6, "seconds": 120, "decision": "Intervalo compartido íntegro; propietario contable seleccionado por función de actividad y referencia timeline de unidad (identidad semántica en empates). Propietario. ", "source_time": "43–45 min", "source_seconds": 120, "is_owner": true, "function": "individual_check"}], "clock_intervals": [6], "presenter_notes": "Reloj fuente 43–45 min: duración compartida 120 segundos. Trabajo: Comprobar la comprensión y cerrar. Función del soporte: comprobación individual.", "shared_intervals": [{"source_index": 6, "source_time": "43–45 min", "seconds": 120, "is_owner": true, "function": "individual_check", "action": "Comprobar la comprensión y cerrar.", "concurrent": false, "parallel_work": ""}]}, "code_blocks": [], "representation_needs": []}</ns0:renderMetadata>
+      <ns0:renderMetadata xmlns:ns0="urn:minijarvis:semantic-render:v1">{"session": "211", "source_files": {"teacher": "/mnt/compartido/Programación-26-27/Minijarvis/02-PROFESORADO/02-SESIONES/h1/S211-constantes-docente.md", "student_fallback": "/mnt/compartido/Programación-26-27/Minijarvis/01-ALUMNADO/03-SESIONES/h1/S211-constantes-alumnado.md"}, "layout": "closure", "plan_index": 7, "recognition": false, "unit_ids": ["unit-17", "unit-19"], "roles": {"unit-17": "core", "unit-19": "core"}, "source_refs": [{"source": "teacher", "heading": "Comprueba lo aprendido", "block_index": 19, "fragment": 0}, {"source": "teacher", "heading": "Al terminar", "block_index": 21, "fragment": 0}], "visible_sources": [{"index": 0, "sha256": "d1e883f1f673c17af930de84df20616b0e9672320f9b22c6a8df1e66e398200b"}, {"index": 2, "sha256": "139edc0da4c423e7db0c409a658663d5a0f2456a703f1ea36786e34fff0c98d3"}, {"index": 3, "sha256": "ed77adc5766e0f42b1d6cff68535cbcac28f722a78b754bfa501b904b5075277"}], "notes_sources": [{"function": "individual_check", "heading": "Comprueba lo aprendido", "sha256": "dae03982d930a360cc6f21f6182bdcfffd59c916b3cd04bb2bc0c7f6a450910a"}, {"function": "individual_check", "heading": "Comprueba lo aprendido", "sha256": "c54f205b33bd0dd1f4ec5e9ca0395c54a3e3633b76fe0bb5b87a0f6041c4f4f5"}, {"function": "continuity", "heading": "Al terminar", "sha256": "c5d760b9336aefe6ba9649ec169c61027094be686b87323b8f689f792abbf42a"}, {"function": "facilitation", "heading": "Comprueba lo aprendido", "sha256": "5ac270c14daf9145b5fa6b3260aaee7fce13571ee2fba5f4f556b6f5b86f5a90"}, {"function": "visible_detail", "heading": "Comprueba lo aprendido", "sha256": "139edc0da4c423e7db0c409a658663d5a0f2456a703f1ea36786e34fff0c98d3"}, {"function": "closure", "heading": "Comprueba lo aprendido", "sha256": "ed77adc5766e0f42b1d6cff68535cbcac28f722a78b754bfa501b904b5075277"}, {"function": "closure", "heading": "Comprueba lo aprendido", "sha256": "d1e883f1f673c17af930de84df20616b0e9672320f9b22c6a8df1e66e398200b"}, {"function": "closure", "heading": "Comprueba lo aprendido", "sha256": "ed77adc5766e0f42b1d6cff68535cbcac28f722a78b754bfa501b904b5075277"}, {"function": "closure", "heading": "Comprueba lo aprendido", "sha256": "d1e883f1f673c17af930de84df20616b0e9672320f9b22c6a8df1e66e398200b"}], "relations": {"unit_relations": {"unit-17": {"question_context": ["context", "question"]}}, "schedule": null, "source_supports_enriched": true}, "timeline_refs": [6], "composition": {"origin_slides": [29]}, "timing": {"seconds": 120, "allocations": [{"source_index": 6, "seconds": 120, "decision": "Intervalo compartido íntegro; propietario contable seleccionado por función de actividad y referencia timeline de unidad (identidad semántica en empates). Propietario. ", "source_time": "43–45 min", "source_seconds": 120, "is_owner": true, "function": "individual_check"}], "clock_intervals": [6], "presenter_notes": "Reloj fuente 43–45 min: duración compartida 120 segundos. Trabajo: Comprobar la comprensión y cerrar. Función del soporte: comprobación individual.", "shared_intervals": [{"source_index": 6, "source_time": "43–45 min", "seconds": 120, "is_owner": true, "function": "individual_check", "action": "Comprobar la comprensión y cerrar.", "concurrent": false, "parallel_work": ""}]}, "code_blocks": [], "representation_needs": []}</ns0:renderMetadata>
     </p:ext>
   </p:extLst>
 </p:sld>
@@ -13924,7 +13448,7 @@
   </p:clrMapOvr>
   <p:extLst>
     <p:ext uri="urn:minijarvis:semantic-render:v1">
-      <ns0:renderMetadata xmlns:ns0="urn:minijarvis:semantic-render:v1">{"session": "211", "source_files": {"teacher": "/mnt/compartido/Programación-26-27/Minijarvis/02-PROFESORADO/02-SESIONES/h1/S211-constantes-docente.md", "student_fallback": "/mnt/compartido/Programación-26-27/Minijarvis/01-ALUMNADO/03-SESIONES/h1/S211-constantes-alumnado.md"}, "layout": "recognition", "plan_index": 1, "recognition": true, "unit_ids": ["unit-6"], "roles": {"unit-6": "recognition"}, "source_refs": [{"source": "teacher", "heading": "Una expresión produce un resultado", "block_index": 7, "fragment": 0}, {"source": "teacher", "heading": "Ideas y ejemplos", "block_index": 4, "fragment": 0}], "visible_sources": [{"index": 20, "sha256": "562859ea1a4afbd61aaea042d301bfd191eb570e4b86f6b2584eb895ee625bde"}, {"index": 21, "sha256": "379433b7200354cefb196f05aed38d7c5233dae0d804528f62fb886300908929"}, {"index": 23, "sha256": "4456aad91c236cb26dfc892dec8d8e079d6f125ca2e3155c3da9198533319b28"}], "notes_sources": [{"function": "visible_detail", "heading": "Una expresión produce un resultado", "sha256": "562859ea1a4afbd61aaea042d301bfd191eb570e4b86f6b2584eb895ee625bde"}, {"function": "facilitation", "heading": "Una expresión produce un resultado", "sha256": "843c52d28a05bcb423518b94511c89e3c448a851556ca2152b0e6dfe1f779ed0"}, {"function": "visible_detail", "heading": "Una expresión produce un resultado", "sha256": "22cbb3b1e032d3a540bfcc3354138a634224a4f306db9e7ed9ee632f1bed623b"}], "relations": {"unit_relations": {"unit-6": {}}, "schedule": null, "presentation_normalizations": {"3 + 2                       -&gt; int\n5 / 2.0                     -&gt; double\nhoras &gt;= 4                  -&gt; boolean\n\"Hola, \" + nombreUsuario    -&gt; String": "3 + 2                       → int\n5 / 2.0                     → double\nhoras &gt;= 4                  → boolean\n\"Hola, \" + nombreUsuario    → String"}, "source_supports_enriched": true}, "timeline_refs": [1], "composition": {"origin_slides": [8, 9]}, "timing": {"seconds": 0, "allocations": [{"source_index": 1, "seconds": 0, "decision": "Intervalo compartido íntegro; propietario contable seleccionado por función de actividad y referencia timeline de unidad (identidad semántica en empates). Soporte, sin duplicación contable. ", "source_time": "4–12 min", "source_seconds": 480, "is_owner": false, "function": "other"}], "clock_intervals": [1], "presenter_notes": "Reloj fuente 4–12 min: duración compartida 480 segundos. Trabajo: Núcleo práctico guiado: final, mapa de literales y expresiones con resultado y tipo. Función del soporte: apoyo al trabajo.", "shared_intervals": [{"source_index": 1, "source_time": "4–12 min", "seconds": 480, "is_owner": false, "function": "other", "action": "Núcleo práctico guiado: final, mapa de literales y expresiones con resultado y tipo.", "concurrent": false, "parallel_work": ""}]}, "code_blocks": ["3 + 2\nhoras * 60\nhoras &gt;= 4\ntieneNombre &amp;&amp; tieneObjetivo\n\"Hola, \" + nombreUsuario"], "representation_needs": [{"source_need": "Representación especial de unidades completas; no truncar", "status": "resolved", "resolution": "Vistas por unidad y fronteras fuente; código íntegro y tipografía fija"}]}</ns0:renderMetadata>
+      <ns0:renderMetadata xmlns:ns0="urn:minijarvis:semantic-render:v1">{"session": "211", "source_files": {"teacher": "/mnt/compartido/Programación-26-27/Minijarvis/02-PROFESORADO/02-SESIONES/h1/S211-constantes-docente.md", "student_fallback": "/mnt/compartido/Programación-26-27/Minijarvis/01-ALUMNADO/03-SESIONES/h1/S211-constantes-alumnado.md"}, "layout": "recognition", "plan_index": 1, "recognition": true, "unit_ids": ["unit-6"], "roles": {"unit-6": "recognition"}, "source_refs": [{"source": "teacher", "heading": "Una expresión produce un resultado", "block_index": 7, "fragment": 0}, {"source": "teacher", "heading": "Ideas y ejemplos", "block_index": 4, "fragment": 0}], "visible_sources": [{"index": 20, "sha256": "562859ea1a4afbd61aaea042d301bfd191eb570e4b86f6b2584eb895ee625bde"}, {"index": 21, "sha256": "379433b7200354cefb196f05aed38d7c5233dae0d804528f62fb886300908929"}, {"index": 23, "sha256": "4456aad91c236cb26dfc892dec8d8e079d6f125ca2e3155c3da9198533319b28"}], "notes_sources": [{"function": "visible_detail", "heading": "Una expresión produce un resultado", "sha256": "562859ea1a4afbd61aaea042d301bfd191eb570e4b86f6b2584eb895ee625bde"}, {"function": "facilitation", "heading": "Una expresión produce un resultado", "sha256": "843c52d28a05bcb423518b94511c89e3c448a851556ca2152b0e6dfe1f779ed0"}, {"function": "visible_detail", "heading": "Una expresión produce un resultado", "sha256": "7b968c98e67987d31f981a91c23a492010cb5c5a4c203c8e0f7d7a52146f26a5"}], "relations": {"unit_relations": {"unit-6": {}}, "schedule": null, "presentation_normalizations": {"3 + 2                       -&gt; int\n5 / 2.0                     -&gt; double\nhoras &gt;= 4                  -&gt; boolean\n\"Hola, \" + nombreUsuario    -&gt; String": "3 + 2                       → int\n5 / 2.0                     → double\nhoras &gt;= 4                  → boolean\n\"Hola, \" + nombreUsuario    → String"}, "source_supports_enriched": true}, "timeline_refs": [1], "composition": {"origin_slides": [8, 9]}, "timing": {"seconds": 0, "allocations": [{"source_index": 1, "seconds": 0, "decision": "Intervalo compartido íntegro; propietario contable seleccionado por función de actividad y referencia timeline de unidad (identidad semántica en empates). Soporte, sin duplicación contable. ", "source_time": "4–12 min", "source_seconds": 480, "is_owner": false, "function": "other"}], "clock_intervals": [1], "presenter_notes": "Reloj fuente 4–12 min: duración compartida 480 segundos. Trabajo: Núcleo práctico guiado: final, mapa de literales y expresiones con resultado y tipo. Función del soporte: apoyo al trabajo.", "shared_intervals": [{"source_index": 1, "source_time": "4–12 min", "seconds": 480, "is_owner": false, "function": "other", "action": "Núcleo práctico guiado: final, mapa de literales y expresiones con resultado y tipo.", "concurrent": false, "parallel_work": ""}]}, "code_blocks": ["3 + 2\nhoras * 60\nhoras &gt;= 4\ntieneNombre &amp;&amp; tieneObjetivo\n\"Hola, \" + nombreUsuario"], "representation_needs": [{"source_need": "Representación especial de unidades completas; no truncar", "status": "resolved", "resolution": "Vistas por unidad y fronteras fuente; código íntegro y tipografía fija"}]}</ns0:renderMetadata>
     </p:ext>
   </p:extLst>
 </p:sld>
@@ -14123,7 +13647,7 @@
   </p:clrMapOvr>
   <p:extLst>
     <p:ext uri="urn:minijarvis:semantic-render:v1">
-      <ns0:renderMetadata xmlns:ns0="urn:minijarvis:semantic-render:v1">{"session": "211", "source_files": {"teacher": "/mnt/compartido/Programación-26-27/Minijarvis/02-PROFESORADO/02-SESIONES/h1/S211-constantes-docente.md", "student_fallback": "/mnt/compartido/Programación-26-27/Minijarvis/01-ALUMNADO/03-SESIONES/h1/S211-constantes-alumnado.md"}, "layout": "recognition", "plan_index": 1, "recognition": true, "unit_ids": ["unit-6"], "roles": {"unit-6": "recognition"}, "source_refs": [{"source": "teacher", "heading": "Una expresión produce un resultado", "block_index": 7, "fragment": 0}, {"source": "teacher", "heading": "Ideas y ejemplos", "block_index": 4, "fragment": 0}], "visible_sources": [{"index": 24, "sha256": "22cbb3b1e032d3a540bfcc3354138a634224a4f306db9e7ed9ee632f1bed623b"}], "notes_sources": [{"function": "visible_detail", "heading": "Una expresión produce un resultado", "sha256": "562859ea1a4afbd61aaea042d301bfd191eb570e4b86f6b2584eb895ee625bde"}, {"function": "facilitation", "heading": "Una expresión produce un resultado", "sha256": "843c52d28a05bcb423518b94511c89e3c448a851556ca2152b0e6dfe1f779ed0"}, {"function": "visible_detail", "heading": "Una expresión produce un resultado", "sha256": "22cbb3b1e032d3a540bfcc3354138a634224a4f306db9e7ed9ee632f1bed623b"}], "relations": {"unit_relations": {"unit-6": {}}, "schedule": null, "source_supports_enriched": true}, "timeline_refs": [1], "composition": {"origin_slides": [8, 9]}, "timing": {"seconds": 0, "allocations": [{"source_index": 1, "seconds": 0, "decision": "Intervalo compartido íntegro; propietario contable seleccionado por función de actividad y referencia timeline de unidad (identidad semántica en empates). Soporte, sin duplicación contable. ", "source_time": "4–12 min", "source_seconds": 480, "is_owner": false, "function": "other"}], "clock_intervals": [1], "presenter_notes": "Reloj fuente 4–12 min: duración compartida 480 segundos. Trabajo: Núcleo práctico guiado: final, mapa de literales y expresiones con resultado y tipo. Función del soporte: apoyo al trabajo.", "shared_intervals": [{"source_index": 1, "source_time": "4–12 min", "seconds": 480, "is_owner": false, "function": "other", "action": "Núcleo práctico guiado: final, mapa de literales y expresiones con resultado y tipo.", "concurrent": false, "parallel_work": ""}]}, "code_blocks": [], "representation_needs": [{"source_need": "Representación especial de unidades completas; no truncar", "status": "resolved", "resolution": "Vistas por unidad y fronteras fuente; código íntegro y tipografía fija"}]}</ns0:renderMetadata>
+      <ns0:renderMetadata xmlns:ns0="urn:minijarvis:semantic-render:v1">{"session": "211", "source_files": {"teacher": "/mnt/compartido/Programación-26-27/Minijarvis/02-PROFESORADO/02-SESIONES/h1/S211-constantes-docente.md", "student_fallback": "/mnt/compartido/Programación-26-27/Minijarvis/01-ALUMNADO/03-SESIONES/h1/S211-constantes-alumnado.md"}, "layout": "recognition", "plan_index": 1, "recognition": true, "unit_ids": ["unit-6"], "roles": {"unit-6": "recognition"}, "source_refs": [{"source": "teacher", "heading": "Una expresión produce un resultado", "block_index": 7, "fragment": 0}, {"source": "teacher", "heading": "Ideas y ejemplos", "block_index": 4, "fragment": 0}], "visible_sources": [{"index": 24, "sha256": "7b968c98e67987d31f981a91c23a492010cb5c5a4c203c8e0f7d7a52146f26a5"}], "notes_sources": [{"function": "visible_detail", "heading": "Una expresión produce un resultado", "sha256": "562859ea1a4afbd61aaea042d301bfd191eb570e4b86f6b2584eb895ee625bde"}, {"function": "facilitation", "heading": "Una expresión produce un resultado", "sha256": "843c52d28a05bcb423518b94511c89e3c448a851556ca2152b0e6dfe1f779ed0"}, {"function": "visible_detail", "heading": "Una expresión produce un resultado", "sha256": "7b968c98e67987d31f981a91c23a492010cb5c5a4c203c8e0f7d7a52146f26a5"}], "relations": {"unit_relations": {"unit-6": {}}, "schedule": null, "source_supports_enriched": true}, "timeline_refs": [1], "composition": {"origin_slides": [8, 9]}, "timing": {"seconds": 0, "allocations": [{"source_index": 1, "seconds": 0, "decision": "Intervalo compartido íntegro; propietario contable seleccionado por función de actividad y referencia timeline de unidad (identidad semántica en empates). Soporte, sin duplicación contable. ", "source_time": "4–12 min", "source_seconds": 480, "is_owner": false, "function": "other"}], "clock_intervals": [1], "presenter_notes": "Reloj fuente 4–12 min: duración compartida 480 segundos. Trabajo: Núcleo práctico guiado: final, mapa de literales y expresiones con resultado y tipo. Función del soporte: apoyo al trabajo.", "shared_intervals": [{"source_index": 1, "source_time": "4–12 min", "seconds": 480, "is_owner": false, "function": "other", "action": "Núcleo práctico guiado: final, mapa de literales y expresiones con resultado y tipo.", "concurrent": false, "parallel_work": ""}]}, "code_blocks": [], "representation_needs": [{"source_need": "Representación especial de unidades completas; no truncar", "status": "resolved", "resolution": "Vistas por unidad y fronteras fuente; código íntegro y tipografía fija"}]}</ns0:renderMetadata>
     </p:ext>
   </p:extLst>
 </p:sld>

</xml_diff>